<commit_message>
update misconception on last slide
</commit_message>
<xml_diff>
--- a/presentations/Weekly presentation - EquiTorch-2025-05-05-weekly.pptx
+++ b/presentations/Weekly presentation - EquiTorch-2025-05-05-weekly.pptx
@@ -3464,69 +3464,21 @@
           <a:bodyPr/>
           <a:lstStyle/>
           <a:p>
-            <a:pPr marL="217170" indent="-217170" defTabSz="868680">
-              <a:spcBef>
-                <a:spcPts val="900"/>
-              </a:spcBef>
-              <a:defRPr sz="2660"/>
-            </a:pPr>
+            <a:pPr/>
             <a:r>
               <a:t>Pytorch fundamentally works based on runtime information</a:t>
             </a:r>
           </a:p>
           <a:p>
-            <a:pPr marL="217170" indent="-217170" defTabSz="868680">
-              <a:spcBef>
-                <a:spcPts val="900"/>
-              </a:spcBef>
-              <a:defRPr sz="2660"/>
-            </a:pPr>
+            <a:pPr/>
             <a:r>
               <a:t>jax/equinox differentiates between static and dynamic information</a:t>
             </a:r>
           </a:p>
           <a:p>
-            <a:pPr marL="217170" indent="-217170" defTabSz="868680">
-              <a:spcBef>
-                <a:spcPts val="900"/>
-              </a:spcBef>
-              <a:defRPr sz="2660"/>
-            </a:pPr>
-            <a:r>
-              <a:t>Without access to runtime information transpilation might be inherently ambigue</a:t>
-            </a:r>
-          </a:p>
-          <a:p>
-            <a:pPr marL="217170" indent="-217170" defTabSz="868680">
-              <a:spcBef>
-                <a:spcPts val="900"/>
-              </a:spcBef>
-              <a:defRPr sz="2660"/>
-            </a:pPr>
-            <a:r>
-              <a:t>Maybe translation can do „runtime-probing“?</a:t>
-            </a:r>
-          </a:p>
-          <a:p>
-            <a:pPr marL="217170" indent="-217170" defTabSz="868680">
-              <a:spcBef>
-                <a:spcPts val="900"/>
-              </a:spcBef>
-              <a:defRPr sz="2660"/>
-            </a:pPr>
-            <a:r>
-              <a:t>Maybe we can find a templating-like solution for some cases?</a:t>
-            </a:r>
-          </a:p>
-          <a:p>
-            <a:pPr marL="217170" indent="-217170" defTabSz="868680">
-              <a:spcBef>
-                <a:spcPts val="900"/>
-              </a:spcBef>
-              <a:defRPr sz="2660"/>
-            </a:pPr>
-            <a:r>
-              <a:t>Both are long shots, lets do basics first.</a:t>
+            <a:pPr/>
+            <a:r>
+              <a:t>JAX comes with tools to handle ambiguous control flows. i.e. adding static arguments and jax.lax TODO: investigate</a:t>
             </a:r>
           </a:p>
         </p:txBody>

</xml_diff>